<commit_message>
Update verification references from 69 to 43 hashes across documentation and code
- Corrected the number of manifest hashes in the README, changelog, and verification log.
- Updated the presentation and presenter notes to reflect the change in hash count.
- Adjusted the verification notebook to check 43 manifest artifacts instead of 69.
- Ensured consistency across all related files and documentation regarding the verification process.
</commit_message>
<xml_diff>
--- a/presentation/Event-TimeRAF_Verified_Presentation.pptx
+++ b/presentation/Event-TimeRAF_Verified_Presentation.pptx
@@ -5820,7 +5820,7 @@
                 </a:solidFill>
                 <a:latin typeface="Aptos"/>
               </a:rPr>
-              <a:t>Verify 69 hashes</a:t>
+              <a:t>Verify 43 hashes</a:t>
             </a:r>
           </a:p>
           <a:p>
@@ -6595,7 +6595,7 @@
                 </a:solidFill>
                 <a:latin typeface="Aptos"/>
               </a:rPr>
-              <a:t>69/69  </a:t>
+              <a:t>43/43  </a:t>
             </a:r>
             <a:r>
               <a:rPr sz="1800">

</xml_diff>